<commit_message>
Rename official captures exactly as in our 01_pcap (all eight datasets)
02_preprocess/00_rename.py places the official files under the names of our
01_pcap; 02_preprocess/lib_rename/<ds>.csv holds the settings per dataset.
vpn16, tor16, tls1.3, cispec and ustc16 were checked byte-identical on the
full official downloads (pcapng conversion, the tor16 capture cut at 16 MiB,
repaired copies, and the ustc16 parts merged with mergecap included); cic17
renames one file per day, cic18 uses the name map made when the captures
were placed, iot23 was matched on the first 64 KiB of all 309 files.
Every placed file is checked for size and first packet.

Also: session keys of iot23; arrange_pcaps.py and the cic18-only tool
removed; DATASETS.md, README and the guide updated.

Co-Authored-By: Claude Opus 5.5 <noreply@anthropic.com>
</commit_message>
<xml_diff>
--- a/99_documents/guide_KU.pptx
+++ b/99_documents/guide_KU.pptx
@@ -6297,7 +6297,7 @@
                 <a:latin typeface="Noto Sans KR"/>
                 <a:ea typeface="Noto Sans KR"/>
               </a:rPr>
-              <a:t>python 00_assets/datasets/_tools/arrange_pcaps.py --dataset vpn16 --src &lt;dl&gt;</a:t>
+              <a:t>python 02_preprocess/00_rename.py --dataset vpn16 --src &lt;dl&gt;</a:t>
             </a:r>
             <a:r>
               <a:rPr sz="1050" b="0" i="0">
@@ -7814,7 +7814,7 @@
                 <a:latin typeface="Noto Sans KR"/>
                 <a:ea typeface="Noto Sans KR"/>
               </a:rPr>
-              <a:t>Eight public datasets: download, arrange, check, align</a:t>
+              <a:t>Eight public datasets: download, rename, check, align</a:t>
             </a:r>
           </a:p>
         </p:txBody>
@@ -11208,7 +11208,7 @@
                 <a:latin typeface="Noto Sans KR"/>
                 <a:ea typeface="Noto Sans KR"/>
               </a:rPr>
-              <a:t>Eight public datasets — official downloads and how each is arranged</a:t>
+              <a:t>Eight public datasets — official files renamed exactly as in our 01_pcap</a:t>
             </a:r>
           </a:p>
         </p:txBody>
@@ -11474,7 +11474,7 @@
                           <a:latin typeface="Noto Sans KR"/>
                           <a:ea typeface="Noto Sans KR"/>
                         </a:rPr>
-                        <a:t>Arrangement (00_assets/datasets/_tools/)</a:t>
+                        <a:t>02_preprocess/00_rename.py — how checked</a:t>
                       </a:r>
                     </a:p>
                   </a:txBody>
@@ -11692,7 +11692,7 @@
                           <a:latin typeface="Noto Sans KR"/>
                           <a:ea typeface="Noto Sans KR"/>
                         </a:rPr>
-                        <a:t>arrange_pcaps.py (keyword rules)</a:t>
+                        <a:t>byte-identical (139 files)</a:t>
                       </a:r>
                     </a:p>
                   </a:txBody>
@@ -11904,7 +11904,7 @@
                           <a:latin typeface="Noto Sans KR"/>
                           <a:ea typeface="Noto Sans KR"/>
                         </a:rPr>
-                        <a:t>arrange_pcaps.py (keyword rules)</a:t>
+                        <a:t>byte-identical (106 files)</a:t>
                       </a:r>
                     </a:p>
                   </a:txBody>
@@ -12116,7 +12116,7 @@
                           <a:latin typeface="Noto Sans KR"/>
                           <a:ea typeface="Noto Sans KR"/>
                         </a:rPr>
-                        <a:t>arrange_pcaps.py (domain folders)</a:t>
+                        <a:t>byte-identical (46,372 files)</a:t>
                       </a:r>
                     </a:p>
                   </a:txBody>
@@ -12328,7 +12328,7 @@
                           <a:latin typeface="Noto Sans KR"/>
                           <a:ea typeface="Noto Sans KR"/>
                         </a:rPr>
-                        <a:t>cispec/relabel_cispec.py</a:t>
+                        <a:t>byte-identical (123,000 files)</a:t>
                       </a:r>
                     </a:p>
                   </a:txBody>
@@ -12540,7 +12540,7 @@
                           <a:latin typeface="Noto Sans KR"/>
                           <a:ea typeface="Noto Sans KR"/>
                         </a:rPr>
-                        <a:t>arrange_pcaps.py (Benign / Malware)</a:t>
+                        <a:t>byte-identical (20; 2 merged)</a:t>
                       </a:r>
                     </a:p>
                   </a:txBody>
@@ -12752,7 +12752,7 @@
                           <a:latin typeface="Noto Sans KR"/>
                           <a:ea typeface="Noto Sans KR"/>
                         </a:rPr>
-                        <a:t>arrange_pcaps.py + official flow labels</a:t>
+                        <a:t>one file per day + flow labels</a:t>
                       </a:r>
                     </a:p>
                   </a:txBody>
@@ -12964,7 +12964,7 @@
                           <a:latin typeface="Noto Sans KR"/>
                           <a:ea typeface="Noto Sans KR"/>
                         </a:rPr>
-                        <a:t>cic18/apply_rename_map.py (4,006 names)</a:t>
+                        <a:t>our name map (4,006 files)</a:t>
                       </a:r>
                     </a:p>
                   </a:txBody>
@@ -13176,7 +13176,7 @@
                           <a:latin typeface="Noto Sans KR"/>
                           <a:ea typeface="Noto Sans KR"/>
                         </a:rPr>
-                        <a:t>arrange_pcaps.py (folder names)</a:t>
+                        <a:t>first 64 KiB identical (309)</a:t>
                       </a:r>
                     </a:p>
                   </a:txBody>
@@ -13736,7 +13736,7 @@
                 <a:latin typeface="Noto Sans KR"/>
                 <a:ea typeface="Noto Sans KR"/>
               </a:rPr>
-              <a:t>download (99_documents/DATASETS.md)</a:t>
+              <a:t>download (DATASETS.md)</a:t>
             </a:r>
           </a:p>
         </p:txBody>
@@ -13876,7 +13876,7 @@
                 <a:latin typeface="Noto Sans KR"/>
                 <a:ea typeface="Noto Sans KR"/>
               </a:rPr>
-              <a:t>Arrange</a:t>
+              <a:t>00_rename.py</a:t>
             </a:r>
           </a:p>
         </p:txBody>
@@ -14689,7 +14689,7 @@
                 <a:latin typeface="Noto Sans KR"/>
                 <a:ea typeface="Noto Sans KR"/>
               </a:rPr>
-              <a:t>    01_dataset/&lt;ds&gt;/session_keys.csv — 7 datasets, iot23 to follow</a:t>
+              <a:t>    01_dataset/&lt;ds&gt;/session_keys.csv — all eight datasets</a:t>
             </a:r>
           </a:p>
           <a:p>

</xml_diff>

<commit_message>
Sync with manuscript ver21: authors, paper map, S1, survey list
- README.md, CITATION.cff, guide_KU: the seven authors of the manuscript
  (Jang, Yu, Nam, Kim, Choi, Baek, Kim)
- PAPER_MAP.md: table, figure, and appendix numbers of the current version
- Supplementary_S1.pdf: current version (rules summarised in Table 5)
- 99_documents/survey/: coded list of the 68 surveyed papers with verbatim
  evidence and sources; one paper excluded after a publisher notice of removal

Co-Authored-By: Claude Opus 5.5 <noreply@anthropic.com>
</commit_message>
<xml_diff>
--- a/99_documents/guide_KU.pptx
+++ b/99_documents/guide_KU.pptx
@@ -3441,7 +3441,7 @@
                 <a:latin typeface="Noto Sans KR"/>
                 <a:ea typeface="Noto Sans KR"/>
               </a:rPr>
-              <a:t>,  Eun-Hyeok Park</a:t>
+              <a:t>,  Seung-Woo Nam</a:t>
             </a:r>
             <a:r>
               <a:rPr sz="1400" b="1" i="0" baseline="30000">
@@ -3461,7 +3461,7 @@
                 <a:latin typeface="Noto Sans KR"/>
                 <a:ea typeface="Noto Sans KR"/>
               </a:rPr>
-              <a:t>,  Gyu-Sang Shim</a:t>
+              <a:t>,  Ju-Sung Kim</a:t>
             </a:r>
             <a:r>
               <a:rPr sz="1400" b="1" i="0" baseline="30000">
@@ -3494,7 +3494,7 @@
                 <a:latin typeface="Noto Sans KR"/>
                 <a:ea typeface="Noto Sans KR"/>
               </a:rPr>
-              <a:t>Ui-Jong Jeong</a:t>
+              <a:t>Yang-Seo Choi</a:t>
             </a:r>
             <a:r>
               <a:rPr sz="1400" b="1" i="0" baseline="30000">
@@ -3504,7 +3504,7 @@
                 <a:latin typeface="Noto Sans KR"/>
                 <a:ea typeface="Noto Sans KR"/>
               </a:rPr>
-              <a:t>1</a:t>
+              <a:t>2</a:t>
             </a:r>
             <a:r>
               <a:rPr sz="1400" b="0" i="0">
@@ -3514,7 +3514,7 @@
                 <a:latin typeface="Noto Sans KR"/>
                 <a:ea typeface="Noto Sans KR"/>
               </a:rPr>
-              <a:t>,  Yang-Seo Choi</a:t>
+              <a:t>,  Ui-Jun Baek</a:t>
             </a:r>
             <a:r>
               <a:rPr sz="1400" b="1" i="0" baseline="30000">
@@ -3524,7 +3524,7 @@
                 <a:latin typeface="Noto Sans KR"/>
                 <a:ea typeface="Noto Sans KR"/>
               </a:rPr>
-              <a:t>2</a:t>
+              <a:t>3</a:t>
             </a:r>
             <a:r>
               <a:rPr sz="1400" b="0" i="0">
@@ -3567,7 +3567,7 @@
                 <a:latin typeface="Noto Sans KR"/>
                 <a:ea typeface="Noto Sans KR"/>
               </a:rPr>
-              <a:t>1 Korea University   2 Electronics and Telecommunications Research Institute   * corresponding author</a:t>
+              <a:t>1 Korea University   2 ETRI   3 KISTI   * corresponding author</a:t>
             </a:r>
           </a:p>
         </p:txBody>

</xml_diff>